<commit_message>
Rehacer la presentacion del Paso 1 con las cifras verificadas
La copia anterior se genero antes de integrar la pasarela de pagos y el
despacho automatico de suscripciones. Las cifras se volvieron a contar
sobre el codigo, no sobre los .md del repositorio:

- 133 pruebas / 336 aserciones (php artisan test), antes 112 / 271
- 28 rutas con nombre (php artisan route:list), antes 25
- 9 tablas y 12 servicios de dominio, antes 8 y 10

Se agregaron las tarjetas de "Pasarela de pagos" (Culqi detras de una
interfaz) y "Despacho automatico" (comando programado a las 03:00), y
"Cobrar con una pasarela real" en la lista de lo que un CMS no resuelve.

Co-Authored-By: Claude Opus 5 <noreply@anthropic.com>
Claude-Session: https://claude.ai/code/session_01SBNMpgU4DA2arm6qA7genT
</commit_message>
<xml_diff>
--- a/docs/presentacion/Paso1_IdentificarLaNecesidad.pptx
+++ b/docs/presentacion/Paso1_IdentificarLaNecesidad.pptx
@@ -1126,7 +1126,7 @@
           <a:p>
             <a:r>
               <a:rPr lang="en-US" dirty="0"/>
-              <a:t>El número 112 no es una estimación: es la salida de php artisan test del día en que se armó esta presentación.</a:t>
+              <a:t>El número 133 no es una estimación: es la salida de php artisan test. Subió de 112 a 133 cuando entraron la pasarela de pagos y el despacho automático de suscripciones.</a:t>
             </a:r>
             <a:endParaRPr lang="en-US" dirty="0"/>
           </a:p>
@@ -1967,7 +1967,7 @@
         </p:nvSpPr>
         <p:spPr>
           <a:xfrm>
-            <a:off x="987552" y="2505456"/>
+            <a:off x="987552" y="2450592"/>
             <a:ext cx="100584" cy="100584"/>
           </a:xfrm>
           <a:prstGeom prst="ellipse">
@@ -1992,7 +1992,7 @@
         </p:nvSpPr>
         <p:spPr>
           <a:xfrm>
-            <a:off x="1225296" y="2395728"/>
+            <a:off x="1225296" y="2340864"/>
             <a:ext cx="4114800" cy="329184"/>
           </a:xfrm>
           <a:prstGeom prst="rect">
@@ -2031,7 +2031,7 @@
         </p:nvSpPr>
         <p:spPr>
           <a:xfrm>
-            <a:off x="987552" y="2907792"/>
+            <a:off x="987552" y="2852928"/>
             <a:ext cx="100584" cy="100584"/>
           </a:xfrm>
           <a:prstGeom prst="ellipse">
@@ -2056,7 +2056,7 @@
         </p:nvSpPr>
         <p:spPr>
           <a:xfrm>
-            <a:off x="1225296" y="2798064"/>
+            <a:off x="1225296" y="2743200"/>
             <a:ext cx="4114800" cy="329184"/>
           </a:xfrm>
           <a:prstGeom prst="rect">
@@ -2095,7 +2095,7 @@
         </p:nvSpPr>
         <p:spPr>
           <a:xfrm>
-            <a:off x="987552" y="3310128"/>
+            <a:off x="987552" y="3255264"/>
             <a:ext cx="100584" cy="100584"/>
           </a:xfrm>
           <a:prstGeom prst="ellipse">
@@ -2120,7 +2120,7 @@
         </p:nvSpPr>
         <p:spPr>
           <a:xfrm>
-            <a:off x="1225296" y="3200400"/>
+            <a:off x="1225296" y="3145536"/>
             <a:ext cx="4114800" cy="329184"/>
           </a:xfrm>
           <a:prstGeom prst="rect">
@@ -2159,7 +2159,7 @@
         </p:nvSpPr>
         <p:spPr>
           <a:xfrm>
-            <a:off x="987552" y="3712464"/>
+            <a:off x="987552" y="3657600"/>
             <a:ext cx="100584" cy="100584"/>
           </a:xfrm>
           <a:prstGeom prst="ellipse">
@@ -2184,7 +2184,7 @@
         </p:nvSpPr>
         <p:spPr>
           <a:xfrm>
-            <a:off x="1225296" y="3602736"/>
+            <a:off x="1225296" y="3547872"/>
             <a:ext cx="4114800" cy="329184"/>
           </a:xfrm>
           <a:prstGeom prst="rect">
@@ -2223,7 +2223,7 @@
         </p:nvSpPr>
         <p:spPr>
           <a:xfrm>
-            <a:off x="987552" y="4114800"/>
+            <a:off x="987552" y="4059936"/>
             <a:ext cx="100584" cy="100584"/>
           </a:xfrm>
           <a:prstGeom prst="ellipse">
@@ -2248,7 +2248,7 @@
         </p:nvSpPr>
         <p:spPr>
           <a:xfrm>
-            <a:off x="1225296" y="4005072"/>
+            <a:off x="1225296" y="3950208"/>
             <a:ext cx="4114800" cy="329184"/>
           </a:xfrm>
           <a:prstGeom prst="rect">
@@ -2287,7 +2287,7 @@
         </p:nvSpPr>
         <p:spPr>
           <a:xfrm>
-            <a:off x="987552" y="4517136"/>
+            <a:off x="987552" y="4462272"/>
             <a:ext cx="100584" cy="100584"/>
           </a:xfrm>
           <a:prstGeom prst="ellipse">
@@ -2312,7 +2312,7 @@
         </p:nvSpPr>
         <p:spPr>
           <a:xfrm>
-            <a:off x="1225296" y="4407408"/>
+            <a:off x="1225296" y="4352544"/>
             <a:ext cx="4114800" cy="329184"/>
           </a:xfrm>
           <a:prstGeom prst="rect">
@@ -2351,7 +2351,7 @@
         </p:nvSpPr>
         <p:spPr>
           <a:xfrm>
-            <a:off x="987552" y="4919472"/>
+            <a:off x="987552" y="4864608"/>
             <a:ext cx="100584" cy="100584"/>
           </a:xfrm>
           <a:prstGeom prst="ellipse">
@@ -2376,7 +2376,7 @@
         </p:nvSpPr>
         <p:spPr>
           <a:xfrm>
-            <a:off x="1225296" y="4809744"/>
+            <a:off x="1225296" y="4754880"/>
             <a:ext cx="4114800" cy="329184"/>
           </a:xfrm>
           <a:prstGeom prst="rect">
@@ -2415,7 +2415,7 @@
         </p:nvSpPr>
         <p:spPr>
           <a:xfrm>
-            <a:off x="987552" y="5321808"/>
+            <a:off x="987552" y="5266944"/>
             <a:ext cx="100584" cy="100584"/>
           </a:xfrm>
           <a:prstGeom prst="ellipse">
@@ -2440,7 +2440,7 @@
         </p:nvSpPr>
         <p:spPr>
           <a:xfrm>
-            <a:off x="1225296" y="5212080"/>
+            <a:off x="1225296" y="5157216"/>
             <a:ext cx="4114800" cy="329184"/>
           </a:xfrm>
           <a:prstGeom prst="rect">
@@ -2465,6 +2465,70 @@
                 <a:ea typeface="Calibri" pitchFamily="34" charset="-122"/>
                 <a:cs typeface="Calibri" pitchFamily="34" charset="-120"/>
               </a:rPr>
+              <a:t>Cobro en línea del pedido</a:t>
+            </a:r>
+            <a:endParaRPr lang="en-US" sz="1350" dirty="0"/>
+          </a:p>
+        </p:txBody>
+      </p:sp>
+      <p:sp>
+        <p:nvSpPr>
+          <p:cNvPr id="22" name="Shape 20"/>
+          <p:cNvSpPr/>
+          <p:nvPr/>
+        </p:nvSpPr>
+        <p:spPr>
+          <a:xfrm>
+            <a:off x="987552" y="5669280"/>
+            <a:ext cx="100584" cy="100584"/>
+          </a:xfrm>
+          <a:prstGeom prst="ellipse">
+            <a:avLst/>
+          </a:prstGeom>
+          <a:solidFill>
+            <a:srgbClr val="E8A33D"/>
+          </a:solidFill>
+          <a:ln w="12700">
+            <a:solidFill>
+              <a:srgbClr val="E8A33D"/>
+            </a:solidFill>
+            <a:prstDash val="solid"/>
+          </a:ln>
+        </p:spPr>
+      </p:sp>
+      <p:sp>
+        <p:nvSpPr>
+          <p:cNvPr id="23" name="Text 21"/>
+          <p:cNvSpPr txBox="1"/>
+          <p:nvPr/>
+        </p:nvSpPr>
+        <p:spPr>
+          <a:xfrm>
+            <a:off x="1225296" y="5559552"/>
+            <a:ext cx="4114800" cy="329184"/>
+          </a:xfrm>
+          <a:prstGeom prst="rect">
+            <a:avLst/>
+          </a:prstGeom>
+          <a:noFill/>
+          <a:ln/>
+        </p:spPr>
+        <p:txBody>
+          <a:bodyPr wrap="square" lIns="0" tIns="0" rIns="0" bIns="0" rtlCol="0" anchor="ctr"/>
+          <a:lstStyle/>
+          <a:p>
+            <a:pPr indent="0" marL="0">
+              <a:buNone/>
+            </a:pPr>
+            <a:r>
+              <a:rPr lang="en-US" sz="1350" dirty="0">
+                <a:solidFill>
+                  <a:srgbClr val="1C2321"/>
+                </a:solidFill>
+                <a:latin typeface="Calibri" pitchFamily="34" charset="0"/>
+                <a:ea typeface="Calibri" pitchFamily="34" charset="-122"/>
+                <a:cs typeface="Calibri" pitchFamily="34" charset="-120"/>
+              </a:rPr>
               <a:t>Acceso por rol del personal</a:t>
             </a:r>
             <a:endParaRPr lang="en-US" sz="1350" dirty="0"/>
@@ -2473,7 +2537,7 @@
       </p:sp>
       <p:sp>
         <p:nvSpPr>
-          <p:cNvPr id="22" name="Text 20"/>
+          <p:cNvPr id="24" name="Text 22"/>
           <p:cNvSpPr txBox="1"/>
           <p:nvPr/>
         </p:nvSpPr>
@@ -2512,7 +2576,7 @@
       </p:sp>
       <p:sp>
         <p:nvSpPr>
-          <p:cNvPr id="23" name="Shape 21"/>
+          <p:cNvPr id="25" name="Shape 23"/>
           <p:cNvSpPr/>
           <p:nvPr/>
         </p:nvSpPr>
@@ -2539,7 +2603,7 @@
       </p:sp>
       <p:sp>
         <p:nvSpPr>
-          <p:cNvPr id="24" name="Text 22"/>
+          <p:cNvPr id="26" name="Text 24"/>
           <p:cNvSpPr txBox="1"/>
           <p:nvPr/>
         </p:nvSpPr>
@@ -2578,7 +2642,7 @@
       </p:sp>
       <p:sp>
         <p:nvSpPr>
-          <p:cNvPr id="25" name="Text 23"/>
+          <p:cNvPr id="27" name="Text 25"/>
           <p:cNvSpPr txBox="1"/>
           <p:nvPr/>
         </p:nvSpPr>
@@ -2617,7 +2681,7 @@
       </p:sp>
       <p:sp>
         <p:nvSpPr>
-          <p:cNvPr id="26" name="Text 24"/>
+          <p:cNvPr id="28" name="Text 26"/>
           <p:cNvSpPr txBox="1"/>
           <p:nvPr/>
         </p:nvSpPr>
@@ -2656,7 +2720,7 @@
       </p:sp>
       <p:sp>
         <p:nvSpPr>
-          <p:cNvPr id="27" name="Text 25"/>
+          <p:cNvPr id="29" name="Text 27"/>
           <p:cNvSpPr txBox="1"/>
           <p:nvPr/>
         </p:nvSpPr>
@@ -3972,7 +4036,7 @@
                 <a:ea typeface="Calibri" pitchFamily="34" charset="-122"/>
                 <a:cs typeface="Calibri" pitchFamily="34" charset="-120"/>
               </a:rPr>
-              <a:t>Catálogo y carrito de compras</a:t>
+              <a:t>Catálogo, carrito y cobro</a:t>
             </a:r>
             <a:endParaRPr lang="en-US" sz="1400" dirty="0"/>
           </a:p>
@@ -4011,7 +4075,7 @@
                 <a:ea typeface="Courier New" pitchFamily="34" charset="-122"/>
                 <a:cs typeface="Courier New" pitchFamily="34" charset="-120"/>
               </a:rPr>
-              <a:t>/app/catalogo  ·  /app/carrito</a:t>
+              <a:t>/app/carrito  ·  /app/pedidos/{id}/pagar</a:t>
             </a:r>
             <a:endParaRPr lang="en-US" sz="1200" dirty="0"/>
           </a:p>
@@ -4182,7 +4246,7 @@
                 <a:ea typeface="Courier New" pitchFamily="34" charset="-122"/>
                 <a:cs typeface="Courier New" pitchFamily="34" charset="-120"/>
               </a:rPr>
-              <a:t>/app/mascotas</a:t>
+              <a:t>/app/suscripciones  ·  comando diario</a:t>
             </a:r>
             <a:endParaRPr lang="en-US" sz="1200" dirty="0"/>
           </a:p>
@@ -4734,7 +4798,7 @@
                 <a:ea typeface="Calibri" pitchFamily="34" charset="-122"/>
                 <a:cs typeface="Calibri" pitchFamily="34" charset="-120"/>
               </a:rPr>
-              <a:t>Las 25 rutas con nombre salen de php artisan route:list, no del documento de la entrega.</a:t>
+              <a:t>Las 28 rutas con nombre salen de php artisan route:list, no del documento de la entrega.</a:t>
             </a:r>
             <a:endParaRPr lang="en-US" sz="1000" dirty="0"/>
           </a:p>
@@ -4967,7 +5031,7 @@
                 <a:ea typeface="Cambria" pitchFamily="34" charset="-122"/>
                 <a:cs typeface="Cambria" pitchFamily="34" charset="-120"/>
               </a:rPr>
-              <a:t>Registro de cuenta</a:t>
+              <a:t>Pasarela de pagos</a:t>
             </a:r>
             <a:endParaRPr lang="en-US" sz="1600" dirty="0"/>
           </a:p>
@@ -5006,7 +5070,7 @@
                 <a:ea typeface="Calibri" pitchFamily="34" charset="-122"/>
                 <a:cs typeface="Calibri" pitchFamily="34" charset="-120"/>
               </a:rPr>
-              <a:t>El cliente crea su propia cuenta. El RF-01 solo hablaba de iniciar sesión.</a:t>
+              <a:t>Cobro en línea con Culqi, detrás de una interfaz que permite cambiar de pasarela.</a:t>
             </a:r>
             <a:endParaRPr lang="en-US" sz="1150" dirty="0"/>
           </a:p>
@@ -5136,7 +5200,7 @@
                 <a:ea typeface="Cambria" pitchFamily="34" charset="-122"/>
                 <a:cs typeface="Cambria" pitchFamily="34" charset="-120"/>
               </a:rPr>
-              <a:t>Alta de productos</a:t>
+              <a:t>Despacho automático</a:t>
             </a:r>
             <a:endParaRPr lang="en-US" sz="1600" dirty="0"/>
           </a:p>
@@ -5175,7 +5239,7 @@
                 <a:ea typeface="Calibri" pitchFamily="34" charset="-122"/>
                 <a:cs typeface="Calibri" pitchFamily="34" charset="-120"/>
               </a:rPr>
-              <a:t>El administrador registra productos desde el dashboard. No figuraba en ningún RF.</a:t>
+              <a:t>Un comando diario genera el pedido de cada suscripción que vence.</a:t>
             </a:r>
             <a:endParaRPr lang="en-US" sz="1150" dirty="0"/>
           </a:p>
@@ -5305,7 +5369,7 @@
                 <a:ea typeface="Cambria" pitchFamily="34" charset="-122"/>
                 <a:cs typeface="Cambria" pitchFamily="34" charset="-120"/>
               </a:rPr>
-              <a:t>Ciclo de estados del pedido</a:t>
+              <a:t>Registro de cuenta</a:t>
             </a:r>
             <a:endParaRPr lang="en-US" sz="1600" dirty="0"/>
           </a:p>
@@ -5344,7 +5408,7 @@
                 <a:ea typeface="Calibri" pitchFamily="34" charset="-122"/>
                 <a:cs typeface="Calibri" pitchFamily="34" charset="-120"/>
               </a:rPr>
-              <a:t>PENDIENTE → PAGADO → ENVIADO → ENTREGADO, sin saltarse pasos.</a:t>
+              <a:t>El cliente crea su propia cuenta. El RF-01 solo hablaba de iniciar sesión.</a:t>
             </a:r>
             <a:endParaRPr lang="en-US" sz="1150" dirty="0"/>
           </a:p>
@@ -5474,7 +5538,7 @@
                 <a:ea typeface="Cambria" pitchFamily="34" charset="-122"/>
                 <a:cs typeface="Cambria" pitchFamily="34" charset="-120"/>
               </a:rPr>
-              <a:t>Desenlace de la cita</a:t>
+              <a:t>Ciclo de estados del pedido</a:t>
             </a:r>
             <a:endParaRPr lang="en-US" sz="1600" dirty="0"/>
           </a:p>
@@ -5513,7 +5577,7 @@
                 <a:ea typeface="Calibri" pitchFamily="34" charset="-122"/>
                 <a:cs typeface="Calibri" pitchFamily="34" charset="-120"/>
               </a:rPr>
-              <a:t>ATENDIDA, CANCELADA o NO_ASISTIO. El RF-04 solo pedía reservarla.</a:t>
+              <a:t>PENDIENTE → PAGADO → ENVIADO → ENTREGADO, sin saltarse pasos.</a:t>
             </a:r>
             <a:endParaRPr lang="en-US" sz="1150" dirty="0"/>
           </a:p>
@@ -5643,7 +5707,7 @@
                 <a:ea typeface="Cambria" pitchFamily="34" charset="-122"/>
                 <a:cs typeface="Cambria" pitchFamily="34" charset="-120"/>
               </a:rPr>
-              <a:t>Pausar y cancelar el plan</a:t>
+              <a:t>Desenlace de la cita</a:t>
             </a:r>
             <a:endParaRPr lang="en-US" sz="1600" dirty="0"/>
           </a:p>
@@ -5682,7 +5746,7 @@
                 <a:ea typeface="Calibri" pitchFamily="34" charset="-122"/>
                 <a:cs typeface="Calibri" pitchFamily="34" charset="-120"/>
               </a:rPr>
-              <a:t>El cliente gobierna su suscripción. El RF-03 solo hablaba de contratarla.</a:t>
+              <a:t>ATENDIDA, CANCELADA o NO_ASISTIO. El RF-04 solo pedía reservarla.</a:t>
             </a:r>
             <a:endParaRPr lang="en-US" sz="1150" dirty="0"/>
           </a:p>
@@ -6568,7 +6632,7 @@
         </p:nvSpPr>
         <p:spPr>
           <a:xfrm>
-            <a:off x="6803136" y="2450592"/>
+            <a:off x="6803136" y="2395728"/>
             <a:ext cx="310896" cy="310896"/>
           </a:xfrm>
           <a:prstGeom prst="rect">
@@ -6607,7 +6671,7 @@
         </p:nvSpPr>
         <p:spPr>
           <a:xfrm>
-            <a:off x="7150608" y="2450592"/>
+            <a:off x="7150608" y="2395728"/>
             <a:ext cx="4206240" cy="292608"/>
           </a:xfrm>
           <a:prstGeom prst="rect">
@@ -6632,6 +6696,123 @@
                 <a:ea typeface="Calibri" pitchFamily="34" charset="-122"/>
                 <a:cs typeface="Calibri" pitchFamily="34" charset="-120"/>
               </a:rPr>
+              <a:t>Cobrar con una pasarela real</a:t>
+            </a:r>
+            <a:endParaRPr lang="en-US" sz="1250" dirty="0"/>
+          </a:p>
+        </p:txBody>
+      </p:sp>
+      <p:sp>
+        <p:nvSpPr>
+          <p:cNvPr id="22" name="Text 20"/>
+          <p:cNvSpPr txBox="1"/>
+          <p:nvPr/>
+        </p:nvSpPr>
+        <p:spPr>
+          <a:xfrm>
+            <a:off x="7150608" y="2670048"/>
+            <a:ext cx="4206240" cy="274320"/>
+          </a:xfrm>
+          <a:prstGeom prst="rect">
+            <a:avLst/>
+          </a:prstGeom>
+          <a:noFill/>
+          <a:ln/>
+        </p:spPr>
+        <p:txBody>
+          <a:bodyPr wrap="square" lIns="0" tIns="0" rIns="0" bIns="0" rtlCol="0" anchor="ctr"/>
+          <a:lstStyle/>
+          <a:p>
+            <a:pPr indent="0" marL="0">
+              <a:buNone/>
+            </a:pPr>
+            <a:r>
+              <a:rPr lang="en-US" sz="1100" dirty="0">
+                <a:solidFill>
+                  <a:srgbClr val="CFE3DC"/>
+                </a:solidFill>
+                <a:latin typeface="Calibri" pitchFamily="34" charset="0"/>
+                <a:ea typeface="Calibri" pitchFamily="34" charset="-122"/>
+                <a:cs typeface="Calibri" pitchFamily="34" charset="-120"/>
+              </a:rPr>
+              <a:t>y registrar el resultado del cargo</a:t>
+            </a:r>
+            <a:endParaRPr lang="en-US" sz="1100" dirty="0"/>
+          </a:p>
+        </p:txBody>
+      </p:sp>
+      <p:sp>
+        <p:nvSpPr>
+          <p:cNvPr id="23" name="Text 21"/>
+          <p:cNvSpPr txBox="1"/>
+          <p:nvPr/>
+        </p:nvSpPr>
+        <p:spPr>
+          <a:xfrm>
+            <a:off x="6803136" y="2962656"/>
+            <a:ext cx="310896" cy="310896"/>
+          </a:xfrm>
+          <a:prstGeom prst="rect">
+            <a:avLst/>
+          </a:prstGeom>
+          <a:noFill/>
+          <a:ln/>
+        </p:spPr>
+        <p:txBody>
+          <a:bodyPr wrap="square" lIns="0" tIns="0" rIns="0" bIns="0" rtlCol="0" anchor="ctr"/>
+          <a:lstStyle/>
+          <a:p>
+            <a:pPr indent="0" marL="0">
+              <a:buNone/>
+            </a:pPr>
+            <a:r>
+              <a:rPr lang="en-US" sz="1400" b="1" dirty="0">
+                <a:solidFill>
+                  <a:srgbClr val="E8A33D"/>
+                </a:solidFill>
+                <a:latin typeface="Calibri" pitchFamily="34" charset="0"/>
+                <a:ea typeface="Calibri" pitchFamily="34" charset="-122"/>
+                <a:cs typeface="Calibri" pitchFamily="34" charset="-120"/>
+              </a:rPr>
+              <a:t>✗</a:t>
+            </a:r>
+            <a:endParaRPr lang="en-US" sz="1400" dirty="0"/>
+          </a:p>
+        </p:txBody>
+      </p:sp>
+      <p:sp>
+        <p:nvSpPr>
+          <p:cNvPr id="24" name="Text 22"/>
+          <p:cNvSpPr txBox="1"/>
+          <p:nvPr/>
+        </p:nvSpPr>
+        <p:spPr>
+          <a:xfrm>
+            <a:off x="7150608" y="2962656"/>
+            <a:ext cx="4206240" cy="292608"/>
+          </a:xfrm>
+          <a:prstGeom prst="rect">
+            <a:avLst/>
+          </a:prstGeom>
+          <a:noFill/>
+          <a:ln/>
+        </p:spPr>
+        <p:txBody>
+          <a:bodyPr wrap="square" lIns="0" tIns="0" rIns="0" bIns="0" rtlCol="0" anchor="ctr"/>
+          <a:lstStyle/>
+          <a:p>
+            <a:pPr indent="0" marL="0">
+              <a:buNone/>
+            </a:pPr>
+            <a:r>
+              <a:rPr lang="en-US" sz="1250" b="1" dirty="0">
+                <a:solidFill>
+                  <a:srgbClr val="FFFFFF"/>
+                </a:solidFill>
+                <a:latin typeface="Calibri" pitchFamily="34" charset="0"/>
+                <a:ea typeface="Calibri" pitchFamily="34" charset="-122"/>
+                <a:cs typeface="Calibri" pitchFamily="34" charset="-120"/>
+              </a:rPr>
               <a:t>Descontar stock dentro de una transacción</a:t>
             </a:r>
             <a:endParaRPr lang="en-US" sz="1250" dirty="0"/>
@@ -6640,13 +6821,13 @@
       </p:sp>
       <p:sp>
         <p:nvSpPr>
-          <p:cNvPr id="22" name="Text 20"/>
-          <p:cNvSpPr txBox="1"/>
-          <p:nvPr/>
-        </p:nvSpPr>
-        <p:spPr>
-          <a:xfrm>
-            <a:off x="7150608" y="2724912"/>
+          <p:cNvPr id="25" name="Text 23"/>
+          <p:cNvSpPr txBox="1"/>
+          <p:nvPr/>
+        </p:nvSpPr>
+        <p:spPr>
+          <a:xfrm>
+            <a:off x="7150608" y="3236976"/>
             <a:ext cx="4206240" cy="274320"/>
           </a:xfrm>
           <a:prstGeom prst="rect">
@@ -6679,13 +6860,13 @@
       </p:sp>
       <p:sp>
         <p:nvSpPr>
-          <p:cNvPr id="23" name="Text 21"/>
-          <p:cNvSpPr txBox="1"/>
-          <p:nvPr/>
-        </p:nvSpPr>
-        <p:spPr>
-          <a:xfrm>
-            <a:off x="6803136" y="3054096"/>
+          <p:cNvPr id="26" name="Text 24"/>
+          <p:cNvSpPr txBox="1"/>
+          <p:nvPr/>
+        </p:nvSpPr>
+        <p:spPr>
+          <a:xfrm>
+            <a:off x="6803136" y="3529584"/>
             <a:ext cx="310896" cy="310896"/>
           </a:xfrm>
           <a:prstGeom prst="rect">
@@ -6718,13 +6899,13 @@
       </p:sp>
       <p:sp>
         <p:nvSpPr>
-          <p:cNvPr id="24" name="Text 22"/>
-          <p:cNvSpPr txBox="1"/>
-          <p:nvPr/>
-        </p:nvSpPr>
-        <p:spPr>
-          <a:xfrm>
-            <a:off x="7150608" y="3054096"/>
+          <p:cNvPr id="27" name="Text 25"/>
+          <p:cNvSpPr txBox="1"/>
+          <p:nvPr/>
+        </p:nvSpPr>
+        <p:spPr>
+          <a:xfrm>
+            <a:off x="7150608" y="3529584"/>
             <a:ext cx="4206240" cy="292608"/>
           </a:xfrm>
           <a:prstGeom prst="rect">
@@ -6757,13 +6938,13 @@
       </p:sp>
       <p:sp>
         <p:nvSpPr>
-          <p:cNvPr id="25" name="Text 23"/>
-          <p:cNvSpPr txBox="1"/>
-          <p:nvPr/>
-        </p:nvSpPr>
-        <p:spPr>
-          <a:xfrm>
-            <a:off x="7150608" y="3328416"/>
+          <p:cNvPr id="28" name="Text 26"/>
+          <p:cNvSpPr txBox="1"/>
+          <p:nvPr/>
+        </p:nvSpPr>
+        <p:spPr>
+          <a:xfrm>
+            <a:off x="7150608" y="3803904"/>
             <a:ext cx="4206240" cy="274320"/>
           </a:xfrm>
           <a:prstGeom prst="rect">
@@ -6796,13 +6977,13 @@
       </p:sp>
       <p:sp>
         <p:nvSpPr>
-          <p:cNvPr id="26" name="Text 24"/>
-          <p:cNvSpPr txBox="1"/>
-          <p:nvPr/>
-        </p:nvSpPr>
-        <p:spPr>
-          <a:xfrm>
-            <a:off x="6803136" y="3657600"/>
+          <p:cNvPr id="29" name="Text 27"/>
+          <p:cNvSpPr txBox="1"/>
+          <p:nvPr/>
+        </p:nvSpPr>
+        <p:spPr>
+          <a:xfrm>
+            <a:off x="6803136" y="4096512"/>
             <a:ext cx="310896" cy="310896"/>
           </a:xfrm>
           <a:prstGeom prst="rect">
@@ -6835,13 +7016,13 @@
       </p:sp>
       <p:sp>
         <p:nvSpPr>
-          <p:cNvPr id="27" name="Text 25"/>
-          <p:cNvSpPr txBox="1"/>
-          <p:nvPr/>
-        </p:nvSpPr>
-        <p:spPr>
-          <a:xfrm>
-            <a:off x="7150608" y="3657600"/>
+          <p:cNvPr id="30" name="Text 28"/>
+          <p:cNvSpPr txBox="1"/>
+          <p:nvPr/>
+        </p:nvSpPr>
+        <p:spPr>
+          <a:xfrm>
+            <a:off x="7150608" y="4096512"/>
             <a:ext cx="4206240" cy="292608"/>
           </a:xfrm>
           <a:prstGeom prst="rect">
@@ -6874,13 +7055,13 @@
       </p:sp>
       <p:sp>
         <p:nvSpPr>
-          <p:cNvPr id="28" name="Text 26"/>
-          <p:cNvSpPr txBox="1"/>
-          <p:nvPr/>
-        </p:nvSpPr>
-        <p:spPr>
-          <a:xfrm>
-            <a:off x="7150608" y="3931920"/>
+          <p:cNvPr id="31" name="Text 29"/>
+          <p:cNvSpPr txBox="1"/>
+          <p:nvPr/>
+        </p:nvSpPr>
+        <p:spPr>
+          <a:xfrm>
+            <a:off x="7150608" y="4370832"/>
             <a:ext cx="4206240" cy="274320"/>
           </a:xfrm>
           <a:prstGeom prst="rect">
@@ -6913,13 +7094,13 @@
       </p:sp>
       <p:sp>
         <p:nvSpPr>
-          <p:cNvPr id="29" name="Text 27"/>
-          <p:cNvSpPr txBox="1"/>
-          <p:nvPr/>
-        </p:nvSpPr>
-        <p:spPr>
-          <a:xfrm>
-            <a:off x="6803136" y="4261104"/>
+          <p:cNvPr id="32" name="Text 30"/>
+          <p:cNvSpPr txBox="1"/>
+          <p:nvPr/>
+        </p:nvSpPr>
+        <p:spPr>
+          <a:xfrm>
+            <a:off x="6803136" y="4663440"/>
             <a:ext cx="310896" cy="310896"/>
           </a:xfrm>
           <a:prstGeom prst="rect">
@@ -6952,13 +7133,13 @@
       </p:sp>
       <p:sp>
         <p:nvSpPr>
-          <p:cNvPr id="30" name="Text 28"/>
-          <p:cNvSpPr txBox="1"/>
-          <p:nvPr/>
-        </p:nvSpPr>
-        <p:spPr>
-          <a:xfrm>
-            <a:off x="7150608" y="4261104"/>
+          <p:cNvPr id="33" name="Text 31"/>
+          <p:cNvSpPr txBox="1"/>
+          <p:nvPr/>
+        </p:nvSpPr>
+        <p:spPr>
+          <a:xfrm>
+            <a:off x="7150608" y="4663440"/>
             <a:ext cx="4206240" cy="292608"/>
           </a:xfrm>
           <a:prstGeom prst="rect">
@@ -6991,13 +7172,13 @@
       </p:sp>
       <p:sp>
         <p:nvSpPr>
-          <p:cNvPr id="31" name="Text 29"/>
-          <p:cNvSpPr txBox="1"/>
-          <p:nvPr/>
-        </p:nvSpPr>
-        <p:spPr>
-          <a:xfrm>
-            <a:off x="7150608" y="4535424"/>
+          <p:cNvPr id="34" name="Text 32"/>
+          <p:cNvSpPr txBox="1"/>
+          <p:nvPr/>
+        </p:nvSpPr>
+        <p:spPr>
+          <a:xfrm>
+            <a:off x="7150608" y="4937760"/>
             <a:ext cx="4206240" cy="274320"/>
           </a:xfrm>
           <a:prstGeom prst="rect">
@@ -7030,13 +7211,13 @@
       </p:sp>
       <p:sp>
         <p:nvSpPr>
-          <p:cNvPr id="32" name="Text 30"/>
-          <p:cNvSpPr txBox="1"/>
-          <p:nvPr/>
-        </p:nvSpPr>
-        <p:spPr>
-          <a:xfrm>
-            <a:off x="6803136" y="4864608"/>
+          <p:cNvPr id="35" name="Text 33"/>
+          <p:cNvSpPr txBox="1"/>
+          <p:nvPr/>
+        </p:nvSpPr>
+        <p:spPr>
+          <a:xfrm>
+            <a:off x="6803136" y="5230368"/>
             <a:ext cx="310896" cy="310896"/>
           </a:xfrm>
           <a:prstGeom prst="rect">
@@ -7069,13 +7250,13 @@
       </p:sp>
       <p:sp>
         <p:nvSpPr>
-          <p:cNvPr id="33" name="Text 31"/>
-          <p:cNvSpPr txBox="1"/>
-          <p:nvPr/>
-        </p:nvSpPr>
-        <p:spPr>
-          <a:xfrm>
-            <a:off x="7150608" y="4864608"/>
+          <p:cNvPr id="36" name="Text 34"/>
+          <p:cNvSpPr txBox="1"/>
+          <p:nvPr/>
+        </p:nvSpPr>
+        <p:spPr>
+          <a:xfrm>
+            <a:off x="7150608" y="5230368"/>
             <a:ext cx="4206240" cy="292608"/>
           </a:xfrm>
           <a:prstGeom prst="rect">
@@ -7108,13 +7289,13 @@
       </p:sp>
       <p:sp>
         <p:nvSpPr>
-          <p:cNvPr id="34" name="Text 32"/>
-          <p:cNvSpPr txBox="1"/>
-          <p:nvPr/>
-        </p:nvSpPr>
-        <p:spPr>
-          <a:xfrm>
-            <a:off x="7150608" y="5138928"/>
+          <p:cNvPr id="37" name="Text 35"/>
+          <p:cNvSpPr txBox="1"/>
+          <p:nvPr/>
+        </p:nvSpPr>
+        <p:spPr>
+          <a:xfrm>
+            <a:off x="7150608" y="5504688"/>
             <a:ext cx="4206240" cy="274320"/>
           </a:xfrm>
           <a:prstGeom prst="rect">
@@ -7139,7 +7320,7 @@
                 <a:ea typeface="Calibri" pitchFamily="34" charset="-122"/>
                 <a:cs typeface="Calibri" pitchFamily="34" charset="-120"/>
               </a:rPr>
-              <a:t>y medir el ingreso que produce</a:t>
+              <a:t>sin que nadie lo dispare a mano</a:t>
             </a:r>
             <a:endParaRPr lang="en-US" sz="1100" dirty="0"/>
           </a:p>
@@ -7147,7 +7328,7 @@
       </p:sp>
       <p:sp>
         <p:nvSpPr>
-          <p:cNvPr id="35" name="Text 33"/>
+          <p:cNvPr id="38" name="Text 36"/>
           <p:cNvSpPr txBox="1"/>
           <p:nvPr/>
         </p:nvSpPr>
@@ -7327,7 +7508,7 @@
                 <a:ea typeface="Cambria" pitchFamily="34" charset="-122"/>
                 <a:cs typeface="Cambria" pitchFamily="34" charset="-120"/>
               </a:rPr>
-              <a:t>25</a:t>
+              <a:t>28</a:t>
             </a:r>
             <a:endParaRPr lang="en-US" sz="6000" dirty="0"/>
           </a:p>
@@ -7428,7 +7609,7 @@
                 <a:ea typeface="Cambria" pitchFamily="34" charset="-122"/>
                 <a:cs typeface="Cambria" pitchFamily="34" charset="-120"/>
               </a:rPr>
-              <a:t>8</a:t>
+              <a:t>9</a:t>
             </a:r>
             <a:endParaRPr lang="en-US" sz="6000" dirty="0"/>
           </a:p>
@@ -7529,7 +7710,7 @@
                 <a:ea typeface="Cambria" pitchFamily="34" charset="-122"/>
                 <a:cs typeface="Cambria" pitchFamily="34" charset="-120"/>
               </a:rPr>
-              <a:t>20</a:t>
+              <a:t>12</a:t>
             </a:r>
             <a:endParaRPr lang="en-US" sz="6000" dirty="0"/>
           </a:p>
@@ -7571,7 +7752,7 @@
                 <a:ea typeface="Calibri" pitchFamily="34" charset="-122"/>
                 <a:cs typeface="Calibri" pitchFamily="34" charset="-120"/>
               </a:rPr>
-              <a:t>reglas de negocio</a:t>
+              <a:t>servicios de</a:t>
             </a:r>
             <a:endParaRPr lang="en-US" sz="1300" dirty="0"/>
           </a:p>
@@ -7591,7 +7772,7 @@
                 <a:ea typeface="Calibri" pitchFamily="34" charset="-122"/>
                 <a:cs typeface="Calibri" pitchFamily="34" charset="-120"/>
               </a:rPr>
-              <a:t>implementadas</a:t>
+              <a:t>dominio</a:t>
             </a:r>
             <a:endParaRPr lang="en-US" sz="1300" dirty="0"/>
           </a:p>
@@ -7630,7 +7811,7 @@
                 <a:ea typeface="Cambria" pitchFamily="34" charset="-122"/>
                 <a:cs typeface="Cambria" pitchFamily="34" charset="-120"/>
               </a:rPr>
-              <a:t>112</a:t>
+              <a:t>133</a:t>
             </a:r>
             <a:endParaRPr lang="en-US" sz="6000" dirty="0"/>
           </a:p>
@@ -7731,7 +7912,7 @@
                 <a:ea typeface="Calibri" pitchFamily="34" charset="-122"/>
                 <a:cs typeface="Calibri" pitchFamily="34" charset="-120"/>
               </a:rPr>
-              <a:t>8 modelos · 9 enums · 5 servicios de dominio</a:t>
+              <a:t>9 modelos · 10 enums · 9 excepciones de regla</a:t>
             </a:r>
             <a:endParaRPr lang="en-US" sz="1300" dirty="0"/>
           </a:p>
@@ -7809,7 +7990,7 @@
                 <a:ea typeface="Calibri" pitchFamily="34" charset="-122"/>
                 <a:cs typeface="Calibri" pitchFamily="34" charset="-120"/>
               </a:rPr>
-              <a:t>16 vistas Blade · 9 controladores · 6 Form Requests</a:t>
+              <a:t>17 vistas Blade · 10 controladores · Form Requests</a:t>
             </a:r>
             <a:endParaRPr lang="en-US" sz="1300" dirty="0"/>
           </a:p>
@@ -8095,7 +8276,7 @@
                 <a:ea typeface="Cambria" pitchFamily="34" charset="-122"/>
                 <a:cs typeface="Cambria" pitchFamily="34" charset="-120"/>
               </a:rPr>
-              <a:t>112</a:t>
+              <a:t>133</a:t>
             </a:r>
             <a:endParaRPr lang="en-US" sz="5600" dirty="0"/>
           </a:p>
@@ -8239,7 +8420,7 @@
                 <a:ea typeface="Cambria" pitchFamily="34" charset="-122"/>
                 <a:cs typeface="Cambria" pitchFamily="34" charset="-120"/>
               </a:rPr>
-              <a:t>271</a:t>
+              <a:t>336</a:t>
             </a:r>
             <a:endParaRPr lang="en-US" sz="5600" dirty="0"/>
           </a:p>
@@ -8383,7 +8564,7 @@
                 <a:ea typeface="Cambria" pitchFamily="34" charset="-122"/>
                 <a:cs typeface="Cambria" pitchFamily="34" charset="-120"/>
               </a:rPr>
-              <a:t>20</a:t>
+              <a:t>12</a:t>
             </a:r>
             <a:endParaRPr lang="en-US" sz="5600" dirty="0"/>
           </a:p>
@@ -8422,7 +8603,7 @@
                 <a:ea typeface="Cambria" pitchFamily="34" charset="-122"/>
                 <a:cs typeface="Cambria" pitchFamily="34" charset="-120"/>
               </a:rPr>
-              <a:t>reglas cubiertas</a:t>
+              <a:t>clases de prueba</a:t>
             </a:r>
             <a:endParaRPr lang="en-US" sz="1800" dirty="0"/>
           </a:p>
@@ -8461,7 +8642,7 @@
                 <a:ea typeface="Calibri" pitchFamily="34" charset="-122"/>
                 <a:cs typeface="Calibri" pitchFamily="34" charset="-120"/>
               </a:rPr>
-              <a:t>De RN-01 a RN-20, cada prueba lleva el código de la regla en su propio nombre.</a:t>
+              <a:t>Una por dominio: cuentas, inventario, carrito, pedido, pago, despacho, suscripción, agenda e historia clínica.</a:t>
             </a:r>
             <a:endParaRPr lang="en-US" sz="1200" dirty="0"/>
           </a:p>
@@ -8945,7 +9126,7 @@
                 <a:ea typeface="Calibri" pitchFamily="34" charset="-122"/>
                 <a:cs typeface="Calibri" pitchFamily="34" charset="-120"/>
               </a:rPr>
-              <a:t>Una aplicación Laravel sobre PHP 8.2 y MySQL, con los módulos de los tres roles y 20 reglas de negocio.</a:t>
+              <a:t>Una aplicación Laravel sobre PHP 8.2 y MySQL, con los módulos de los tres roles, cobro en línea y despacho automático.</a:t>
             </a:r>
             <a:endParaRPr lang="en-US" sz="1300" dirty="0"/>
           </a:p>
@@ -9050,7 +9231,7 @@
                 <a:ea typeface="Calibri" pitchFamily="34" charset="-122"/>
                 <a:cs typeface="Calibri" pitchFamily="34" charset="-120"/>
               </a:rPr>
-              <a:t>112 pruebas automatizadas contra base de datos real, y un recorrido de navegador sobre la aplicación.</a:t>
+              <a:t>133 pruebas automatizadas contra base de datos real, y un recorrido de navegador sobre la aplicación.</a:t>
             </a:r>
             <a:endParaRPr lang="en-US" sz="1300" dirty="0"/>
           </a:p>

</xml_diff>